<commit_message>
Update presentation with talk track notes
Co-authored-by: Copilot <223556219+Copilot@users.noreply.github.com>
</commit_message>
<xml_diff>
--- a/WWC Presentation.pptx
+++ b/WWC Presentation.pptx
@@ -4,6 +4,9 @@
   <p:sldMasterIdLst>
     <p:sldMasterId id="2147483660" r:id="rId1"/>
   </p:sldMasterIdLst>
+  <p:notesMasterIdLst>
+    <p:notesMasterId r:id="rId22"/>
+  </p:notesMasterIdLst>
   <p:sldIdLst>
     <p:sldId id="257" r:id="rId2"/>
     <p:sldId id="258" r:id="rId3"/>
@@ -124,6 +127,870 @@
     </a:lvl9pPr>
   </p:defaultTextStyle>
 </p:presentation>
+</file>
+
+<file path=ppt/revisionInfo.xml><?xml version="1.0" encoding="utf-8"?>
+<p1510:revInfo xmlns:a="http://schemas.openxmlformats.org/drawingml/2006/main" xmlns:r="http://schemas.openxmlformats.org/officeDocument/2006/relationships" xmlns:p1510="http://schemas.microsoft.com/office/powerpoint/2015/10/main">
+  <p1510:revLst>
+    <p1510:client id="{26DE2D38-F947-4D95-B190-0D86CB478197}" v="2" dt="2026-06-01T22:28:54.611"/>
+  </p1510:revLst>
+</p1510:revInfo>
+</file>
+
+<file path=ppt/notesMasters/notesMaster1.xml><?xml version="1.0" encoding="utf-8"?>
+<p:notesMaster xmlns:a="http://schemas.openxmlformats.org/drawingml/2006/main" xmlns:r="http://schemas.openxmlformats.org/officeDocument/2006/relationships" xmlns:p="http://schemas.openxmlformats.org/presentationml/2006/main">
+  <p:cSld>
+    <p:bg>
+      <p:bgRef idx="1001">
+        <a:schemeClr val="bg1"/>
+      </p:bgRef>
+    </p:bg>
+    <p:spTree>
+      <p:nvGrpSpPr>
+        <p:cNvPr id="1" name=""/>
+        <p:cNvGrpSpPr/>
+        <p:nvPr/>
+      </p:nvGrpSpPr>
+      <p:grpSpPr>
+        <a:xfrm>
+          <a:off x="0" y="0"/>
+          <a:ext cx="0" cy="0"/>
+          <a:chOff x="0" y="0"/>
+          <a:chExt cx="0" cy="0"/>
+        </a:xfrm>
+      </p:grpSpPr>
+      <p:sp>
+        <p:nvSpPr>
+          <p:cNvPr id="2" name="Header Placeholder 1"/>
+          <p:cNvSpPr>
+            <a:spLocks noGrp="1"/>
+          </p:cNvSpPr>
+          <p:nvPr>
+            <p:ph type="hdr" sz="quarter"/>
+          </p:nvPr>
+        </p:nvSpPr>
+        <p:spPr>
+          <a:xfrm>
+            <a:off x="0" y="0"/>
+            <a:ext cx="2971800" cy="458788"/>
+          </a:xfrm>
+          <a:prstGeom prst="rect">
+            <a:avLst/>
+          </a:prstGeom>
+        </p:spPr>
+        <p:txBody>
+          <a:bodyPr vert="horz" lIns="91440" tIns="45720" rIns="91440" bIns="45720" rtlCol="0"/>
+          <a:lstStyle>
+            <a:lvl1pPr algn="l">
+              <a:defRPr sz="1200"/>
+            </a:lvl1pPr>
+          </a:lstStyle>
+          <a:p>
+            <a:endParaRPr lang="en-US"/>
+          </a:p>
+        </p:txBody>
+      </p:sp>
+      <p:sp>
+        <p:nvSpPr>
+          <p:cNvPr id="3" name="Date Placeholder 2"/>
+          <p:cNvSpPr>
+            <a:spLocks noGrp="1"/>
+          </p:cNvSpPr>
+          <p:nvPr>
+            <p:ph type="dt" idx="1"/>
+          </p:nvPr>
+        </p:nvSpPr>
+        <p:spPr>
+          <a:xfrm>
+            <a:off x="3884613" y="0"/>
+            <a:ext cx="2971800" cy="458788"/>
+          </a:xfrm>
+          <a:prstGeom prst="rect">
+            <a:avLst/>
+          </a:prstGeom>
+        </p:spPr>
+        <p:txBody>
+          <a:bodyPr vert="horz" lIns="91440" tIns="45720" rIns="91440" bIns="45720" rtlCol="0"/>
+          <a:lstStyle>
+            <a:lvl1pPr algn="r">
+              <a:defRPr sz="1200"/>
+            </a:lvl1pPr>
+          </a:lstStyle>
+          <a:p>
+            <a:fld id="{67670F6B-5B66-4BDC-B49F-86565B8A7125}" type="datetimeFigureOut">
+              <a:rPr lang="en-US" smtClean="0"/>
+              <a:t>5/31/2026</a:t>
+            </a:fld>
+            <a:endParaRPr lang="en-US"/>
+          </a:p>
+        </p:txBody>
+      </p:sp>
+      <p:sp>
+        <p:nvSpPr>
+          <p:cNvPr id="4" name="Slide Image Placeholder 3"/>
+          <p:cNvSpPr>
+            <a:spLocks noGrp="1" noRot="1" noChangeAspect="1"/>
+          </p:cNvSpPr>
+          <p:nvPr>
+            <p:ph type="sldImg" idx="2"/>
+          </p:nvPr>
+        </p:nvSpPr>
+        <p:spPr>
+          <a:xfrm>
+            <a:off x="685800" y="1143000"/>
+            <a:ext cx="5486400" cy="3086100"/>
+          </a:xfrm>
+          <a:prstGeom prst="rect">
+            <a:avLst/>
+          </a:prstGeom>
+          <a:noFill/>
+          <a:ln w="12700">
+            <a:solidFill>
+              <a:prstClr val="black"/>
+            </a:solidFill>
+          </a:ln>
+        </p:spPr>
+        <p:txBody>
+          <a:bodyPr vert="horz" lIns="91440" tIns="45720" rIns="91440" bIns="45720" rtlCol="0" anchor="ctr"/>
+          <a:lstStyle/>
+          <a:p>
+            <a:endParaRPr lang="en-US"/>
+          </a:p>
+        </p:txBody>
+      </p:sp>
+      <p:sp>
+        <p:nvSpPr>
+          <p:cNvPr id="5" name="Notes Placeholder 4"/>
+          <p:cNvSpPr>
+            <a:spLocks noGrp="1"/>
+          </p:cNvSpPr>
+          <p:nvPr>
+            <p:ph type="body" sz="quarter" idx="3"/>
+          </p:nvPr>
+        </p:nvSpPr>
+        <p:spPr>
+          <a:xfrm>
+            <a:off x="685800" y="4400550"/>
+            <a:ext cx="5486400" cy="3600450"/>
+          </a:xfrm>
+          <a:prstGeom prst="rect">
+            <a:avLst/>
+          </a:prstGeom>
+        </p:spPr>
+        <p:txBody>
+          <a:bodyPr vert="horz" lIns="91440" tIns="45720" rIns="91440" bIns="45720" rtlCol="0"/>
+          <a:lstStyle/>
+          <a:p>
+            <a:pPr lvl="0"/>
+            <a:r>
+              <a:rPr lang="en-US"/>
+              <a:t>Click to edit Master text styles</a:t>
+            </a:r>
+          </a:p>
+          <a:p>
+            <a:pPr lvl="1"/>
+            <a:r>
+              <a:rPr lang="en-US"/>
+              <a:t>Second level</a:t>
+            </a:r>
+          </a:p>
+          <a:p>
+            <a:pPr lvl="2"/>
+            <a:r>
+              <a:rPr lang="en-US"/>
+              <a:t>Third level</a:t>
+            </a:r>
+          </a:p>
+          <a:p>
+            <a:pPr lvl="3"/>
+            <a:r>
+              <a:rPr lang="en-US"/>
+              <a:t>Fourth level</a:t>
+            </a:r>
+          </a:p>
+          <a:p>
+            <a:pPr lvl="4"/>
+            <a:r>
+              <a:rPr lang="en-US"/>
+              <a:t>Fifth level</a:t>
+            </a:r>
+          </a:p>
+        </p:txBody>
+      </p:sp>
+      <p:sp>
+        <p:nvSpPr>
+          <p:cNvPr id="6" name="Footer Placeholder 5"/>
+          <p:cNvSpPr>
+            <a:spLocks noGrp="1"/>
+          </p:cNvSpPr>
+          <p:nvPr>
+            <p:ph type="ftr" sz="quarter" idx="4"/>
+          </p:nvPr>
+        </p:nvSpPr>
+        <p:spPr>
+          <a:xfrm>
+            <a:off x="0" y="8685213"/>
+            <a:ext cx="2971800" cy="458787"/>
+          </a:xfrm>
+          <a:prstGeom prst="rect">
+            <a:avLst/>
+          </a:prstGeom>
+        </p:spPr>
+        <p:txBody>
+          <a:bodyPr vert="horz" lIns="91440" tIns="45720" rIns="91440" bIns="45720" rtlCol="0" anchor="b"/>
+          <a:lstStyle>
+            <a:lvl1pPr algn="l">
+              <a:defRPr sz="1200"/>
+            </a:lvl1pPr>
+          </a:lstStyle>
+          <a:p>
+            <a:endParaRPr lang="en-US"/>
+          </a:p>
+        </p:txBody>
+      </p:sp>
+      <p:sp>
+        <p:nvSpPr>
+          <p:cNvPr id="7" name="Slide Number Placeholder 6"/>
+          <p:cNvSpPr>
+            <a:spLocks noGrp="1"/>
+          </p:cNvSpPr>
+          <p:nvPr>
+            <p:ph type="sldNum" sz="quarter" idx="5"/>
+          </p:nvPr>
+        </p:nvSpPr>
+        <p:spPr>
+          <a:xfrm>
+            <a:off x="3884613" y="8685213"/>
+            <a:ext cx="2971800" cy="458787"/>
+          </a:xfrm>
+          <a:prstGeom prst="rect">
+            <a:avLst/>
+          </a:prstGeom>
+        </p:spPr>
+        <p:txBody>
+          <a:bodyPr vert="horz" lIns="91440" tIns="45720" rIns="91440" bIns="45720" rtlCol="0" anchor="b"/>
+          <a:lstStyle>
+            <a:lvl1pPr algn="r">
+              <a:defRPr sz="1200"/>
+            </a:lvl1pPr>
+          </a:lstStyle>
+          <a:p>
+            <a:fld id="{BFB207C7-816C-4417-AC97-CDAC549469E7}" type="slidenum">
+              <a:rPr lang="en-US" smtClean="0"/>
+              <a:t>‹#›</a:t>
+            </a:fld>
+            <a:endParaRPr lang="en-US"/>
+          </a:p>
+        </p:txBody>
+      </p:sp>
+    </p:spTree>
+    <p:extLst>
+      <p:ext uri="{BB962C8B-B14F-4D97-AF65-F5344CB8AC3E}">
+        <p14:creationId xmlns:p14="http://schemas.microsoft.com/office/powerpoint/2010/main" val="151946209"/>
+      </p:ext>
+    </p:extLst>
+  </p:cSld>
+  <p:clrMap bg1="lt1" tx1="dk1" bg2="lt2" tx2="dk2" accent1="accent1" accent2="accent2" accent3="accent3" accent4="accent4" accent5="accent5" accent6="accent6" hlink="hlink" folHlink="folHlink"/>
+  <p:notesStyle>
+    <a:lvl1pPr marL="0" algn="l" defTabSz="914400" rtl="0" eaLnBrk="1" latinLnBrk="0" hangingPunct="1">
+      <a:defRPr sz="1200" kern="1200">
+        <a:solidFill>
+          <a:schemeClr val="tx1"/>
+        </a:solidFill>
+        <a:latin typeface="+mn-lt"/>
+        <a:ea typeface="+mn-ea"/>
+        <a:cs typeface="+mn-cs"/>
+      </a:defRPr>
+    </a:lvl1pPr>
+    <a:lvl2pPr marL="457200" algn="l" defTabSz="914400" rtl="0" eaLnBrk="1" latinLnBrk="0" hangingPunct="1">
+      <a:defRPr sz="1200" kern="1200">
+        <a:solidFill>
+          <a:schemeClr val="tx1"/>
+        </a:solidFill>
+        <a:latin typeface="+mn-lt"/>
+        <a:ea typeface="+mn-ea"/>
+        <a:cs typeface="+mn-cs"/>
+      </a:defRPr>
+    </a:lvl2pPr>
+    <a:lvl3pPr marL="914400" algn="l" defTabSz="914400" rtl="0" eaLnBrk="1" latinLnBrk="0" hangingPunct="1">
+      <a:defRPr sz="1200" kern="1200">
+        <a:solidFill>
+          <a:schemeClr val="tx1"/>
+        </a:solidFill>
+        <a:latin typeface="+mn-lt"/>
+        <a:ea typeface="+mn-ea"/>
+        <a:cs typeface="+mn-cs"/>
+      </a:defRPr>
+    </a:lvl3pPr>
+    <a:lvl4pPr marL="1371600" algn="l" defTabSz="914400" rtl="0" eaLnBrk="1" latinLnBrk="0" hangingPunct="1">
+      <a:defRPr sz="1200" kern="1200">
+        <a:solidFill>
+          <a:schemeClr val="tx1"/>
+        </a:solidFill>
+        <a:latin typeface="+mn-lt"/>
+        <a:ea typeface="+mn-ea"/>
+        <a:cs typeface="+mn-cs"/>
+      </a:defRPr>
+    </a:lvl4pPr>
+    <a:lvl5pPr marL="1828800" algn="l" defTabSz="914400" rtl="0" eaLnBrk="1" latinLnBrk="0" hangingPunct="1">
+      <a:defRPr sz="1200" kern="1200">
+        <a:solidFill>
+          <a:schemeClr val="tx1"/>
+        </a:solidFill>
+        <a:latin typeface="+mn-lt"/>
+        <a:ea typeface="+mn-ea"/>
+        <a:cs typeface="+mn-cs"/>
+      </a:defRPr>
+    </a:lvl5pPr>
+    <a:lvl6pPr marL="2286000" algn="l" defTabSz="914400" rtl="0" eaLnBrk="1" latinLnBrk="0" hangingPunct="1">
+      <a:defRPr sz="1200" kern="1200">
+        <a:solidFill>
+          <a:schemeClr val="tx1"/>
+        </a:solidFill>
+        <a:latin typeface="+mn-lt"/>
+        <a:ea typeface="+mn-ea"/>
+        <a:cs typeface="+mn-cs"/>
+      </a:defRPr>
+    </a:lvl6pPr>
+    <a:lvl7pPr marL="2743200" algn="l" defTabSz="914400" rtl="0" eaLnBrk="1" latinLnBrk="0" hangingPunct="1">
+      <a:defRPr sz="1200" kern="1200">
+        <a:solidFill>
+          <a:schemeClr val="tx1"/>
+        </a:solidFill>
+        <a:latin typeface="+mn-lt"/>
+        <a:ea typeface="+mn-ea"/>
+        <a:cs typeface="+mn-cs"/>
+      </a:defRPr>
+    </a:lvl7pPr>
+    <a:lvl8pPr marL="3200400" algn="l" defTabSz="914400" rtl="0" eaLnBrk="1" latinLnBrk="0" hangingPunct="1">
+      <a:defRPr sz="1200" kern="1200">
+        <a:solidFill>
+          <a:schemeClr val="tx1"/>
+        </a:solidFill>
+        <a:latin typeface="+mn-lt"/>
+        <a:ea typeface="+mn-ea"/>
+        <a:cs typeface="+mn-cs"/>
+      </a:defRPr>
+    </a:lvl8pPr>
+    <a:lvl9pPr marL="3657600" algn="l" defTabSz="914400" rtl="0" eaLnBrk="1" latinLnBrk="0" hangingPunct="1">
+      <a:defRPr sz="1200" kern="1200">
+        <a:solidFill>
+          <a:schemeClr val="tx1"/>
+        </a:solidFill>
+        <a:latin typeface="+mn-lt"/>
+        <a:ea typeface="+mn-ea"/>
+        <a:cs typeface="+mn-cs"/>
+      </a:defRPr>
+    </a:lvl9pPr>
+  </p:notesStyle>
+</p:notesMaster>
+</file>
+
+<file path=ppt/notesSlides/notesSlide1.xml><?xml version="1.0" encoding="utf-8"?>
+<p:notes xmlns:a="http://schemas.openxmlformats.org/drawingml/2006/main" xmlns:r="http://schemas.openxmlformats.org/officeDocument/2006/relationships" xmlns:p="http://schemas.openxmlformats.org/presentationml/2006/main">
+  <p:cSld>
+    <p:spTree>
+      <p:nvGrpSpPr>
+        <p:cNvPr id="1" name=""/>
+        <p:cNvGrpSpPr/>
+        <p:nvPr/>
+      </p:nvGrpSpPr>
+      <p:grpSpPr>
+        <a:xfrm>
+          <a:off x="0" y="0"/>
+          <a:ext cx="0" cy="0"/>
+          <a:chOff x="0" y="0"/>
+          <a:chExt cx="0" cy="0"/>
+        </a:xfrm>
+      </p:grpSpPr>
+      <p:sp>
+        <p:nvSpPr>
+          <p:cNvPr id="2" name="Slide Image Placeholder 1"/>
+          <p:cNvSpPr>
+            <a:spLocks noGrp="1" noRot="1" noChangeAspect="1"/>
+          </p:cNvSpPr>
+          <p:nvPr>
+            <p:ph type="sldImg"/>
+          </p:nvPr>
+        </p:nvSpPr>
+        <p:spPr/>
+      </p:sp>
+      <p:sp>
+        <p:nvSpPr>
+          <p:cNvPr id="3" name="Notes Placeholder 2"/>
+          <p:cNvSpPr>
+            <a:spLocks noGrp="1"/>
+          </p:cNvSpPr>
+          <p:nvPr>
+            <p:ph type="body" idx="1"/>
+          </p:nvPr>
+        </p:nvSpPr>
+        <p:spPr/>
+        <p:txBody>
+          <a:bodyPr/>
+          <a:lstStyle/>
+          <a:p>
+            <a:r>
+              <a:rPr lang="en-US" dirty="0"/>
+              <a:t>Key points:</a:t>
+            </a:r>
+          </a:p>
+          <a:p>
+            <a:pPr marL="228600" indent="-228600">
+              <a:buAutoNum type="arabicPeriod"/>
+            </a:pPr>
+            <a:r>
+              <a:rPr lang="en-US" dirty="0"/>
+              <a:t>We have an industry-wide challenge connecting customer feedback to action, and this gap is even wider for AI products</a:t>
+            </a:r>
+          </a:p>
+          <a:p>
+            <a:pPr marL="228600" indent="-228600">
+              <a:buAutoNum type="arabicPeriod"/>
+            </a:pPr>
+            <a:r>
+              <a:rPr lang="en-US" dirty="0"/>
+              <a:t>Then I’m going to talk about some useful tools and automation we can use to close that gap.</a:t>
+            </a:r>
+          </a:p>
+        </p:txBody>
+      </p:sp>
+      <p:sp>
+        <p:nvSpPr>
+          <p:cNvPr id="4" name="Slide Number Placeholder 3"/>
+          <p:cNvSpPr>
+            <a:spLocks noGrp="1"/>
+          </p:cNvSpPr>
+          <p:nvPr>
+            <p:ph type="sldNum" sz="quarter" idx="5"/>
+          </p:nvPr>
+        </p:nvSpPr>
+        <p:spPr/>
+        <p:txBody>
+          <a:bodyPr/>
+          <a:lstStyle/>
+          <a:p>
+            <a:fld id="{BFB207C7-816C-4417-AC97-CDAC549469E7}" type="slidenum">
+              <a:rPr lang="en-US" smtClean="0"/>
+              <a:t>1</a:t>
+            </a:fld>
+            <a:endParaRPr lang="en-US"/>
+          </a:p>
+        </p:txBody>
+      </p:sp>
+    </p:spTree>
+    <p:extLst>
+      <p:ext uri="{BB962C8B-B14F-4D97-AF65-F5344CB8AC3E}">
+        <p14:creationId xmlns:p14="http://schemas.microsoft.com/office/powerpoint/2010/main" val="3236620034"/>
+      </p:ext>
+    </p:extLst>
+  </p:cSld>
+  <p:clrMapOvr>
+    <a:masterClrMapping/>
+  </p:clrMapOvr>
+</p:notes>
+</file>
+
+<file path=ppt/notesSlides/notesSlide2.xml><?xml version="1.0" encoding="utf-8"?>
+<p:notes xmlns:a="http://schemas.openxmlformats.org/drawingml/2006/main" xmlns:r="http://schemas.openxmlformats.org/officeDocument/2006/relationships" xmlns:p="http://schemas.openxmlformats.org/presentationml/2006/main">
+  <p:cSld>
+    <p:spTree>
+      <p:nvGrpSpPr>
+        <p:cNvPr id="1" name=""/>
+        <p:cNvGrpSpPr/>
+        <p:nvPr/>
+      </p:nvGrpSpPr>
+      <p:grpSpPr>
+        <a:xfrm>
+          <a:off x="0" y="0"/>
+          <a:ext cx="0" cy="0"/>
+          <a:chOff x="0" y="0"/>
+          <a:chExt cx="0" cy="0"/>
+        </a:xfrm>
+      </p:grpSpPr>
+      <p:sp>
+        <p:nvSpPr>
+          <p:cNvPr id="2" name="Slide Image Placeholder 1"/>
+          <p:cNvSpPr>
+            <a:spLocks noGrp="1" noRot="1" noChangeAspect="1"/>
+          </p:cNvSpPr>
+          <p:nvPr>
+            <p:ph type="sldImg"/>
+          </p:nvPr>
+        </p:nvSpPr>
+        <p:spPr/>
+      </p:sp>
+      <p:sp>
+        <p:nvSpPr>
+          <p:cNvPr id="3" name="Notes Placeholder 2"/>
+          <p:cNvSpPr>
+            <a:spLocks noGrp="1"/>
+          </p:cNvSpPr>
+          <p:nvPr>
+            <p:ph type="body" idx="1"/>
+          </p:nvPr>
+        </p:nvSpPr>
+        <p:spPr/>
+        <p:txBody>
+          <a:bodyPr/>
+          <a:lstStyle/>
+          <a:p>
+            <a:r>
+              <a:rPr lang="en-US" dirty="0"/>
+              <a:t> - 28% of feedback experts already use AI for collecting and analyzing customer feedback — HubSpot   (https://blog.hubspot.com/service/ai-customer-feedback-analysis)   - 81% of CX leaders say AI-powered feedback analytics is a top priority, but only 7% have fully mature automation —   </a:t>
+            </a:r>
+            <a:r>
+              <a:rPr lang="en-US" dirty="0" err="1"/>
+              <a:t>Zonka</a:t>
+            </a:r>
+            <a:r>
+              <a:rPr lang="en-US" dirty="0"/>
+              <a:t> Feedback (https://www.zonkafeedback.com/blog/ai-transforming-customer-feedback-analysis)</a:t>
+            </a:r>
+          </a:p>
+        </p:txBody>
+      </p:sp>
+      <p:sp>
+        <p:nvSpPr>
+          <p:cNvPr id="4" name="Slide Number Placeholder 3"/>
+          <p:cNvSpPr>
+            <a:spLocks noGrp="1"/>
+          </p:cNvSpPr>
+          <p:nvPr>
+            <p:ph type="sldNum" sz="quarter" idx="5"/>
+          </p:nvPr>
+        </p:nvSpPr>
+        <p:spPr/>
+        <p:txBody>
+          <a:bodyPr/>
+          <a:lstStyle/>
+          <a:p>
+            <a:fld id="{BFB207C7-816C-4417-AC97-CDAC549469E7}" type="slidenum">
+              <a:rPr lang="en-US" smtClean="0"/>
+              <a:t>4</a:t>
+            </a:fld>
+            <a:endParaRPr lang="en-US"/>
+          </a:p>
+        </p:txBody>
+      </p:sp>
+    </p:spTree>
+    <p:extLst>
+      <p:ext uri="{BB962C8B-B14F-4D97-AF65-F5344CB8AC3E}">
+        <p14:creationId xmlns:p14="http://schemas.microsoft.com/office/powerpoint/2010/main" val="3881933997"/>
+      </p:ext>
+    </p:extLst>
+  </p:cSld>
+  <p:clrMapOvr>
+    <a:masterClrMapping/>
+  </p:clrMapOvr>
+</p:notes>
+</file>
+
+<file path=ppt/notesSlides/notesSlide3.xml><?xml version="1.0" encoding="utf-8"?>
+<p:notes xmlns:a="http://schemas.openxmlformats.org/drawingml/2006/main" xmlns:r="http://schemas.openxmlformats.org/officeDocument/2006/relationships" xmlns:p="http://schemas.openxmlformats.org/presentationml/2006/main">
+  <p:cSld>
+    <p:spTree>
+      <p:nvGrpSpPr>
+        <p:cNvPr id="1" name=""/>
+        <p:cNvGrpSpPr/>
+        <p:nvPr/>
+      </p:nvGrpSpPr>
+      <p:grpSpPr>
+        <a:xfrm>
+          <a:off x="0" y="0"/>
+          <a:ext cx="0" cy="0"/>
+          <a:chOff x="0" y="0"/>
+          <a:chExt cx="0" cy="0"/>
+        </a:xfrm>
+      </p:grpSpPr>
+      <p:sp>
+        <p:nvSpPr>
+          <p:cNvPr id="2" name="Slide Image Placeholder 1"/>
+          <p:cNvSpPr>
+            <a:spLocks noGrp="1" noRot="1" noChangeAspect="1"/>
+          </p:cNvSpPr>
+          <p:nvPr>
+            <p:ph type="sldImg"/>
+          </p:nvPr>
+        </p:nvSpPr>
+        <p:spPr/>
+      </p:sp>
+      <p:sp>
+        <p:nvSpPr>
+          <p:cNvPr id="3" name="Notes Placeholder 2"/>
+          <p:cNvSpPr>
+            <a:spLocks noGrp="1"/>
+          </p:cNvSpPr>
+          <p:nvPr>
+            <p:ph type="body" idx="1"/>
+          </p:nvPr>
+        </p:nvSpPr>
+        <p:spPr/>
+        <p:txBody>
+          <a:bodyPr/>
+          <a:lstStyle/>
+          <a:p>
+            <a:r>
+              <a:rPr lang="en-US" dirty="0"/>
+              <a:t>Deterministic: Username + password (works every time</a:t>
+            </a:r>
+          </a:p>
+          <a:p>
+            <a:r>
+              <a:rPr lang="en-US" dirty="0"/>
+              <a:t>Non0deterministic: Tell me which discount I should give this customer based on their purchase history </a:t>
+            </a:r>
+          </a:p>
+          <a:p>
+            <a:endParaRPr lang="en-US" dirty="0"/>
+          </a:p>
+        </p:txBody>
+      </p:sp>
+      <p:sp>
+        <p:nvSpPr>
+          <p:cNvPr id="4" name="Slide Number Placeholder 3"/>
+          <p:cNvSpPr>
+            <a:spLocks noGrp="1"/>
+          </p:cNvSpPr>
+          <p:nvPr>
+            <p:ph type="sldNum" sz="quarter" idx="5"/>
+          </p:nvPr>
+        </p:nvSpPr>
+        <p:spPr/>
+        <p:txBody>
+          <a:bodyPr/>
+          <a:lstStyle/>
+          <a:p>
+            <a:fld id="{BFB207C7-816C-4417-AC97-CDAC549469E7}" type="slidenum">
+              <a:rPr lang="en-US" smtClean="0"/>
+              <a:t>5</a:t>
+            </a:fld>
+            <a:endParaRPr lang="en-US"/>
+          </a:p>
+        </p:txBody>
+      </p:sp>
+    </p:spTree>
+    <p:extLst>
+      <p:ext uri="{BB962C8B-B14F-4D97-AF65-F5344CB8AC3E}">
+        <p14:creationId xmlns:p14="http://schemas.microsoft.com/office/powerpoint/2010/main" val="1371238963"/>
+      </p:ext>
+    </p:extLst>
+  </p:cSld>
+  <p:clrMapOvr>
+    <a:masterClrMapping/>
+  </p:clrMapOvr>
+</p:notes>
+</file>
+
+<file path=ppt/notesSlides/notesSlide4.xml><?xml version="1.0" encoding="utf-8"?>
+<p:notes xmlns:a="http://schemas.openxmlformats.org/drawingml/2006/main" xmlns:r="http://schemas.openxmlformats.org/officeDocument/2006/relationships" xmlns:p="http://schemas.openxmlformats.org/presentationml/2006/main">
+  <p:cSld>
+    <p:spTree>
+      <p:nvGrpSpPr>
+        <p:cNvPr id="1" name=""/>
+        <p:cNvGrpSpPr/>
+        <p:nvPr/>
+      </p:nvGrpSpPr>
+      <p:grpSpPr>
+        <a:xfrm>
+          <a:off x="0" y="0"/>
+          <a:ext cx="0" cy="0"/>
+          <a:chOff x="0" y="0"/>
+          <a:chExt cx="0" cy="0"/>
+        </a:xfrm>
+      </p:grpSpPr>
+      <p:sp>
+        <p:nvSpPr>
+          <p:cNvPr id="2" name="Slide Image Placeholder 1"/>
+          <p:cNvSpPr>
+            <a:spLocks noGrp="1" noRot="1" noChangeAspect="1"/>
+          </p:cNvSpPr>
+          <p:nvPr>
+            <p:ph type="sldImg"/>
+          </p:nvPr>
+        </p:nvSpPr>
+        <p:spPr/>
+      </p:sp>
+      <p:sp>
+        <p:nvSpPr>
+          <p:cNvPr id="3" name="Notes Placeholder 2"/>
+          <p:cNvSpPr>
+            <a:spLocks noGrp="1"/>
+          </p:cNvSpPr>
+          <p:nvPr>
+            <p:ph type="body" idx="1"/>
+          </p:nvPr>
+        </p:nvSpPr>
+        <p:spPr/>
+        <p:txBody>
+          <a:bodyPr/>
+          <a:lstStyle/>
+          <a:p>
+            <a:endParaRPr lang="en-US" dirty="0"/>
+          </a:p>
+        </p:txBody>
+      </p:sp>
+      <p:sp>
+        <p:nvSpPr>
+          <p:cNvPr id="4" name="Slide Number Placeholder 3"/>
+          <p:cNvSpPr>
+            <a:spLocks noGrp="1"/>
+          </p:cNvSpPr>
+          <p:nvPr>
+            <p:ph type="sldNum" sz="quarter" idx="5"/>
+          </p:nvPr>
+        </p:nvSpPr>
+        <p:spPr/>
+        <p:txBody>
+          <a:bodyPr/>
+          <a:lstStyle/>
+          <a:p>
+            <a:fld id="{BFB207C7-816C-4417-AC97-CDAC549469E7}" type="slidenum">
+              <a:rPr lang="en-US" smtClean="0"/>
+              <a:t>10</a:t>
+            </a:fld>
+            <a:endParaRPr lang="en-US"/>
+          </a:p>
+        </p:txBody>
+      </p:sp>
+    </p:spTree>
+    <p:extLst>
+      <p:ext uri="{BB962C8B-B14F-4D97-AF65-F5344CB8AC3E}">
+        <p14:creationId xmlns:p14="http://schemas.microsoft.com/office/powerpoint/2010/main" val="3647145598"/>
+      </p:ext>
+    </p:extLst>
+  </p:cSld>
+  <p:clrMapOvr>
+    <a:masterClrMapping/>
+  </p:clrMapOvr>
+</p:notes>
+</file>
+
+<file path=ppt/notesSlides/notesSlide5.xml><?xml version="1.0" encoding="utf-8"?>
+<p:notes xmlns:a="http://schemas.openxmlformats.org/drawingml/2006/main" xmlns:r="http://schemas.openxmlformats.org/officeDocument/2006/relationships" xmlns:p="http://schemas.openxmlformats.org/presentationml/2006/main">
+  <p:cSld>
+    <p:spTree>
+      <p:nvGrpSpPr>
+        <p:cNvPr id="1" name=""/>
+        <p:cNvGrpSpPr/>
+        <p:nvPr/>
+      </p:nvGrpSpPr>
+      <p:grpSpPr>
+        <a:xfrm>
+          <a:off x="0" y="0"/>
+          <a:ext cx="0" cy="0"/>
+          <a:chOff x="0" y="0"/>
+          <a:chExt cx="0" cy="0"/>
+        </a:xfrm>
+      </p:grpSpPr>
+      <p:sp>
+        <p:nvSpPr>
+          <p:cNvPr id="2" name="Slide Image Placeholder 1"/>
+          <p:cNvSpPr>
+            <a:spLocks noGrp="1" noRot="1" noChangeAspect="1"/>
+          </p:cNvSpPr>
+          <p:nvPr>
+            <p:ph type="sldImg"/>
+          </p:nvPr>
+        </p:nvSpPr>
+        <p:spPr/>
+      </p:sp>
+      <p:sp>
+        <p:nvSpPr>
+          <p:cNvPr id="3" name="Notes Placeholder 2"/>
+          <p:cNvSpPr>
+            <a:spLocks noGrp="1"/>
+          </p:cNvSpPr>
+          <p:nvPr>
+            <p:ph type="body" idx="1"/>
+          </p:nvPr>
+        </p:nvSpPr>
+        <p:spPr/>
+        <p:txBody>
+          <a:bodyPr/>
+          <a:lstStyle/>
+          <a:p>
+            <a:r>
+              <a:rPr lang="en-US" dirty="0"/>
+              <a:t>Just </a:t>
+            </a:r>
+            <a:r>
+              <a:rPr lang="en-US"/>
+              <a:t>to summarize: our </a:t>
+            </a:r>
+            <a:r>
+              <a:rPr lang="en-US" dirty="0"/>
+              <a:t>customers really do know more about AI than we do, in the sense that they're using our products every day in real production environments. They see the gaps before we </a:t>
+            </a:r>
+            <a:r>
+              <a:rPr lang="en-US" dirty="0" err="1"/>
+              <a:t>do.But</a:t>
+            </a:r>
+            <a:r>
+              <a:rPr lang="en-US" dirty="0"/>
+              <a:t> the good news is we now have tools that help us address that feedback at scale and make sure nothing falls through the </a:t>
+            </a:r>
+            <a:r>
+              <a:rPr lang="en-US" dirty="0" err="1"/>
+              <a:t>cracks.If</a:t>
+            </a:r>
+            <a:r>
+              <a:rPr lang="en-US" dirty="0"/>
+              <a:t> you'd like to try the skills I showed today, you can fork the repo at aka.ms/</a:t>
+            </a:r>
+            <a:r>
+              <a:rPr lang="en-US" dirty="0" err="1"/>
+              <a:t>feedbackanalyzer</a:t>
+            </a:r>
+            <a:r>
+              <a:rPr lang="en-US" dirty="0"/>
+              <a:t>. And I'd love to see skills that you're building to tackle customer feedback in your own workflows — contributions are absolutely </a:t>
+            </a:r>
+            <a:r>
+              <a:rPr lang="en-US" dirty="0" err="1"/>
+              <a:t>welcome.Any</a:t>
+            </a:r>
+            <a:r>
+              <a:rPr lang="en-US" dirty="0"/>
+              <a:t> questions before we close?</a:t>
+            </a:r>
+          </a:p>
+        </p:txBody>
+      </p:sp>
+      <p:sp>
+        <p:nvSpPr>
+          <p:cNvPr id="4" name="Slide Number Placeholder 3"/>
+          <p:cNvSpPr>
+            <a:spLocks noGrp="1"/>
+          </p:cNvSpPr>
+          <p:nvPr>
+            <p:ph type="sldNum" sz="quarter" idx="5"/>
+          </p:nvPr>
+        </p:nvSpPr>
+        <p:spPr/>
+        <p:txBody>
+          <a:bodyPr/>
+          <a:lstStyle/>
+          <a:p>
+            <a:fld id="{BFB207C7-816C-4417-AC97-CDAC549469E7}" type="slidenum">
+              <a:rPr lang="en-US" smtClean="0"/>
+              <a:t>20</a:t>
+            </a:fld>
+            <a:endParaRPr lang="en-US"/>
+          </a:p>
+        </p:txBody>
+      </p:sp>
+    </p:spTree>
+    <p:extLst>
+      <p:ext uri="{BB962C8B-B14F-4D97-AF65-F5344CB8AC3E}">
+        <p14:creationId xmlns:p14="http://schemas.microsoft.com/office/powerpoint/2010/main" val="1114078416"/>
+      </p:ext>
+    </p:extLst>
+  </p:cSld>
+  <p:clrMapOvr>
+    <a:masterClrMapping/>
+  </p:clrMapOvr>
+</p:notes>
 </file>
 
 <file path=ppt/slideLayouts/slideLayout1.xml><?xml version="1.0" encoding="utf-8"?>
@@ -3799,7 +4666,7 @@
         <p:spPr>
           <a:xfrm>
             <a:off x="1097280" y="1691640"/>
-            <a:ext cx="4297680" cy="457200"/>
+            <a:ext cx="4553580" cy="369332"/>
           </a:xfrm>
           <a:prstGeom prst="rect">
             <a:avLst/>
@@ -3835,7 +4702,7 @@
               </a:defRPr>
             </a:pPr>
             <a:r>
-              <a:rPr kumimoji="0" sz="1800" b="1" i="0" u="none" strike="noStrike" kern="1200" cap="none" spc="0" normalizeH="0" baseline="0" noProof="0">
+              <a:rPr kumimoji="0" sz="1800" b="1" i="0" u="none" strike="noStrike" kern="1200" cap="none" spc="0" normalizeH="0" baseline="0" noProof="0" dirty="0">
                 <a:ln>
                   <a:noFill/>
                 </a:ln>
@@ -3851,6 +4718,37 @@
               </a:rPr>
               <a:t>Skill 1: Weekly Feedback Analyzer</a:t>
             </a:r>
+            <a:r>
+              <a:rPr kumimoji="0" lang="en-US" sz="1800" b="1" i="0" u="none" strike="noStrike" kern="1200" cap="none" spc="0" normalizeH="0" baseline="0" noProof="0" dirty="0">
+                <a:ln>
+                  <a:noFill/>
+                </a:ln>
+                <a:solidFill>
+                  <a:srgbClr val="00B294"/>
+                </a:solidFill>
+                <a:effectLst/>
+                <a:uLnTx/>
+                <a:uFillTx/>
+                <a:latin typeface="Segoe UI"/>
+                <a:ea typeface="+mn-ea"/>
+                <a:cs typeface="+mn-cs"/>
+              </a:rPr>
+              <a:t> Skill</a:t>
+            </a:r>
+            <a:endParaRPr kumimoji="0" sz="1800" b="1" i="0" u="none" strike="noStrike" kern="1200" cap="none" spc="0" normalizeH="0" baseline="0" noProof="0" dirty="0">
+              <a:ln>
+                <a:noFill/>
+              </a:ln>
+              <a:solidFill>
+                <a:srgbClr val="00B294"/>
+              </a:solidFill>
+              <a:effectLst/>
+              <a:uLnTx/>
+              <a:uFillTx/>
+              <a:latin typeface="Segoe UI"/>
+              <a:ea typeface="+mn-ea"/>
+              <a:cs typeface="+mn-cs"/>
+            </a:endParaRPr>
           </a:p>
         </p:txBody>
       </p:sp>
@@ -4600,7 +5498,7 @@
         <p:spPr>
           <a:xfrm>
             <a:off x="6705295" y="1691640"/>
-            <a:ext cx="4297680" cy="457200"/>
+            <a:ext cx="4754880" cy="369332"/>
           </a:xfrm>
           <a:prstGeom prst="rect">
             <a:avLst/>
@@ -4636,7 +5534,7 @@
               </a:defRPr>
             </a:pPr>
             <a:r>
-              <a:rPr kumimoji="0" sz="1800" b="1" i="0" u="none" strike="noStrike" kern="1200" cap="none" spc="0" normalizeH="0" baseline="0" noProof="0">
+              <a:rPr kumimoji="0" sz="1800" b="1" i="0" u="none" strike="noStrike" kern="1200" cap="none" spc="0" normalizeH="0" baseline="0" noProof="0" dirty="0">
                 <a:ln>
                   <a:noFill/>
                 </a:ln>
@@ -4652,6 +5550,37 @@
               </a:rPr>
               <a:t>Skill 2: Cumulative Feedback Report</a:t>
             </a:r>
+            <a:r>
+              <a:rPr kumimoji="0" lang="en-US" sz="1800" b="1" i="0" u="none" strike="noStrike" kern="1200" cap="none" spc="0" normalizeH="0" baseline="0" noProof="0" dirty="0">
+                <a:ln>
+                  <a:noFill/>
+                </a:ln>
+                <a:solidFill>
+                  <a:srgbClr val="9B59B6"/>
+                </a:solidFill>
+                <a:effectLst/>
+                <a:uLnTx/>
+                <a:uFillTx/>
+                <a:latin typeface="Segoe UI"/>
+                <a:ea typeface="+mn-ea"/>
+                <a:cs typeface="+mn-cs"/>
+              </a:rPr>
+              <a:t> Skill</a:t>
+            </a:r>
+            <a:endParaRPr kumimoji="0" sz="1800" b="1" i="0" u="none" strike="noStrike" kern="1200" cap="none" spc="0" normalizeH="0" baseline="0" noProof="0" dirty="0">
+              <a:ln>
+                <a:noFill/>
+              </a:ln>
+              <a:solidFill>
+                <a:srgbClr val="9B59B6"/>
+              </a:solidFill>
+              <a:effectLst/>
+              <a:uLnTx/>
+              <a:uFillTx/>
+              <a:latin typeface="Segoe UI"/>
+              <a:ea typeface="+mn-ea"/>
+              <a:cs typeface="+mn-cs"/>
+            </a:endParaRPr>
           </a:p>
         </p:txBody>
       </p:sp>
@@ -5742,7 +6671,7 @@
         <p:spPr>
           <a:xfrm>
             <a:off x="258953" y="1764832"/>
-            <a:ext cx="6096000" cy="2585323"/>
+            <a:ext cx="6096000" cy="2862322"/>
           </a:xfrm>
           <a:prstGeom prst="rect">
             <a:avLst/>
@@ -5787,7 +6716,59 @@
                 <a:ea typeface="+mn-ea"/>
                 <a:cs typeface="+mn-cs"/>
               </a:rPr>
-              <a:t>Prompt:   </a:t>
+              <a:t>Example </a:t>
+            </a:r>
+            <a:r>
+              <a:rPr lang="en-US" dirty="0">
+                <a:solidFill>
+                  <a:prstClr val="white"/>
+                </a:solidFill>
+                <a:latin typeface="Calibri"/>
+              </a:rPr>
+              <a:t>p</a:t>
+            </a:r>
+            <a:r>
+              <a:rPr kumimoji="0" lang="en-US" sz="1800" b="0" i="0" u="none" strike="noStrike" kern="1200" cap="none" spc="0" normalizeH="0" baseline="0" noProof="0" dirty="0" err="1">
+                <a:ln>
+                  <a:noFill/>
+                </a:ln>
+                <a:solidFill>
+                  <a:prstClr val="white"/>
+                </a:solidFill>
+                <a:effectLst/>
+                <a:uLnTx/>
+                <a:uFillTx/>
+                <a:latin typeface="Calibri"/>
+                <a:ea typeface="+mn-ea"/>
+                <a:cs typeface="+mn-cs"/>
+              </a:rPr>
+              <a:t>rompt</a:t>
+            </a:r>
+            <a:r>
+              <a:rPr lang="en-US" dirty="0">
+                <a:solidFill>
+                  <a:prstClr val="white"/>
+                </a:solidFill>
+                <a:latin typeface="Calibri"/>
+              </a:rPr>
+              <a:t> to create the skill: </a:t>
+            </a:r>
+            <a:r>
+              <a:rPr kumimoji="0" lang="en-US" sz="1800" b="0" i="0" u="none" strike="noStrike" kern="1200" cap="none" spc="0" normalizeH="0" baseline="0" noProof="0" dirty="0">
+                <a:ln>
+                  <a:noFill/>
+                </a:ln>
+                <a:solidFill>
+                  <a:prstClr val="white"/>
+                </a:solidFill>
+                <a:effectLst/>
+                <a:uLnTx/>
+                <a:uFillTx/>
+                <a:latin typeface="Calibri"/>
+                <a:ea typeface="+mn-ea"/>
+                <a:cs typeface="+mn-cs"/>
+              </a:rPr>
+              <a:t>   </a:t>
             </a:r>
           </a:p>
           <a:p>
@@ -5856,7 +6837,33 @@
                 <a:ea typeface="+mn-ea"/>
                 <a:cs typeface="+mn-cs"/>
               </a:rPr>
-              <a:t>Build me a skill that reads all my customer feedback notes from meeting transcripts, tickets, Teams conversations, and existing notes in my customer feedback folder and generates a report showing top trends, feature requests ranked by priority, bugs by severity, sentiment with real quotes, and recommended actions. Run the skill through security review to ensure all data is protected. Include an HTML dashboard with charts.</a:t>
+              <a:t>Build me a skill that reads all my customer feedback notes from meeting transcripts, tickets, Teams conversations, and existing notes in my customer feedback folder and generates a report showing top trends, feature requests ranked by priority, bugs by severity, sentiment with real quotes, weighted feedback </a:t>
+            </a:r>
+            <a:r>
+              <a:rPr lang="en-US" dirty="0">
+                <a:solidFill>
+                  <a:prstClr val="white"/>
+                </a:solidFill>
+                <a:latin typeface="Calibri"/>
+              </a:rPr>
+              <a:t>based on top customers, </a:t>
+            </a:r>
+            <a:r>
+              <a:rPr kumimoji="0" lang="en-US" sz="1800" b="0" i="0" u="none" strike="noStrike" kern="1200" cap="none" spc="0" normalizeH="0" baseline="0" noProof="0" dirty="0">
+                <a:ln>
+                  <a:noFill/>
+                </a:ln>
+                <a:solidFill>
+                  <a:prstClr val="white"/>
+                </a:solidFill>
+                <a:effectLst/>
+                <a:uLnTx/>
+                <a:uFillTx/>
+                <a:latin typeface="Calibri"/>
+                <a:ea typeface="+mn-ea"/>
+                <a:cs typeface="+mn-cs"/>
+              </a:rPr>
+              <a:t>and recommended actions. Run the skill through security review to ensure all data is protected. Include an HTML dashboard with charts.</a:t>
             </a:r>
           </a:p>
         </p:txBody>
@@ -12870,7 +13877,7 @@
         <p:spPr>
           <a:xfrm>
             <a:off x="1371600" y="868680"/>
-            <a:ext cx="9418320" cy="457200"/>
+            <a:ext cx="9418320" cy="338554"/>
           </a:xfrm>
           <a:prstGeom prst="rect">
             <a:avLst/>
@@ -12920,7 +13927,75 @@
                 <a:ea typeface="+mn-ea"/>
                 <a:cs typeface="+mn-cs"/>
               </a:rPr>
-              <a:t>Plain-text markdown skills. No vendor lock-in. Drop them into any AI assistant.</a:t>
+              <a:t>Plain-text markdown skills. No vendor lock-in. </a:t>
+            </a:r>
+            <a:r>
+              <a:rPr kumimoji="0" lang="en-US" sz="1600" b="0" i="0" u="none" strike="noStrike" kern="1200" cap="none" spc="0" normalizeH="0" baseline="0" noProof="0" dirty="0">
+                <a:ln>
+                  <a:noFill/>
+                </a:ln>
+                <a:solidFill>
+                  <a:srgbClr val="8B949E"/>
+                </a:solidFill>
+                <a:effectLst/>
+                <a:uLnTx/>
+                <a:uFillTx/>
+                <a:latin typeface="Segoe UI"/>
+                <a:ea typeface="+mn-ea"/>
+                <a:cs typeface="+mn-cs"/>
+              </a:rPr>
+              <a:t>Use with any</a:t>
+            </a:r>
+            <a:r>
+              <a:rPr kumimoji="0" sz="1600" b="0" i="0" u="none" strike="noStrike" kern="1200" cap="none" spc="0" normalizeH="0" baseline="0" noProof="0" dirty="0">
+                <a:ln>
+                  <a:noFill/>
+                </a:ln>
+                <a:solidFill>
+                  <a:srgbClr val="8B949E"/>
+                </a:solidFill>
+                <a:effectLst/>
+                <a:uLnTx/>
+                <a:uFillTx/>
+                <a:latin typeface="Segoe UI"/>
+                <a:ea typeface="+mn-ea"/>
+                <a:cs typeface="+mn-cs"/>
+              </a:rPr>
+              <a:t> AI</a:t>
+            </a:r>
+            <a:r>
+              <a:rPr kumimoji="0" lang="en-US" sz="1600" b="0" i="0" u="none" strike="noStrike" kern="1200" cap="none" spc="0" normalizeH="0" baseline="0" noProof="0" dirty="0">
+                <a:ln>
+                  <a:noFill/>
+                </a:ln>
+                <a:solidFill>
+                  <a:srgbClr val="8B949E"/>
+                </a:solidFill>
+                <a:effectLst/>
+                <a:uLnTx/>
+                <a:uFillTx/>
+                <a:latin typeface="Segoe UI"/>
+                <a:ea typeface="+mn-ea"/>
+                <a:cs typeface="+mn-cs"/>
+              </a:rPr>
+              <a:t> tool (local repo or web tool)</a:t>
+            </a:r>
+            <a:r>
+              <a:rPr kumimoji="0" sz="1600" b="0" i="0" u="none" strike="noStrike" kern="1200" cap="none" spc="0" normalizeH="0" baseline="0" noProof="0" dirty="0">
+                <a:ln>
+                  <a:noFill/>
+                </a:ln>
+                <a:solidFill>
+                  <a:srgbClr val="8B949E"/>
+                </a:solidFill>
+                <a:effectLst/>
+                <a:uLnTx/>
+                <a:uFillTx/>
+                <a:latin typeface="Segoe UI"/>
+                <a:ea typeface="+mn-ea"/>
+                <a:cs typeface="+mn-cs"/>
+              </a:rPr>
+              <a:t>.</a:t>
             </a:r>
           </a:p>
         </p:txBody>
@@ -20482,7 +21557,7 @@
         <p:spPr>
           <a:xfrm>
             <a:off x="731520" y="1097280"/>
-            <a:ext cx="10972800" cy="365760"/>
+            <a:ext cx="5296643" cy="369332"/>
           </a:xfrm>
           <a:prstGeom prst="rect">
             <a:avLst/>
@@ -20517,7 +21592,7 @@
               </a:defRPr>
             </a:pPr>
             <a:r>
-              <a:rPr kumimoji="0" sz="1800" b="0" i="1" u="none" strike="noStrike" kern="1200" cap="none" spc="0" normalizeH="0" baseline="0" noProof="0">
+              <a:rPr kumimoji="0" sz="1800" b="0" i="1" u="none" strike="noStrike" kern="1200" cap="none" spc="0" normalizeH="0" baseline="0" noProof="0" dirty="0">
                 <a:ln>
                   <a:noFill/>
                 </a:ln>
@@ -20531,8 +21606,31 @@
                 <a:ea typeface="+mn-ea"/>
                 <a:cs typeface="+mn-cs"/>
               </a:rPr>
-              <a:t>Teams aren’t ignoring customers. The system is broken.</a:t>
-            </a:r>
+              <a:t>Teams aren’t ignoring customers. </a:t>
+            </a:r>
+            <a:r>
+              <a:rPr lang="en-US" i="1" dirty="0">
+                <a:solidFill>
+                  <a:srgbClr val="8899BB"/>
+                </a:solidFill>
+                <a:latin typeface="Calibri"/>
+              </a:rPr>
+              <a:t>It’s just complicated.</a:t>
+            </a:r>
+            <a:endParaRPr kumimoji="0" sz="1800" b="0" i="1" u="none" strike="noStrike" kern="1200" cap="none" spc="0" normalizeH="0" baseline="0" noProof="0" dirty="0">
+              <a:ln>
+                <a:noFill/>
+              </a:ln>
+              <a:solidFill>
+                <a:srgbClr val="8899BB"/>
+              </a:solidFill>
+              <a:effectLst/>
+              <a:uLnTx/>
+              <a:uFillTx/>
+              <a:latin typeface="Calibri"/>
+              <a:ea typeface="+mn-ea"/>
+              <a:cs typeface="+mn-cs"/>
+            </a:endParaRPr>
           </a:p>
         </p:txBody>
       </p:sp>
@@ -27368,6 +28466,321 @@
 </a:theme>
 </file>
 
+<file path=ppt/theme/theme2.xml><?xml version="1.0" encoding="utf-8"?>
+<a:theme xmlns:a="http://schemas.openxmlformats.org/drawingml/2006/main" name="Office Theme">
+  <a:themeElements>
+    <a:clrScheme name="Office">
+      <a:dk1>
+        <a:sysClr val="windowText" lastClr="000000"/>
+      </a:dk1>
+      <a:lt1>
+        <a:sysClr val="window" lastClr="FFFFFF"/>
+      </a:lt1>
+      <a:dk2>
+        <a:srgbClr val="0E2841"/>
+      </a:dk2>
+      <a:lt2>
+        <a:srgbClr val="E8E8E8"/>
+      </a:lt2>
+      <a:accent1>
+        <a:srgbClr val="156082"/>
+      </a:accent1>
+      <a:accent2>
+        <a:srgbClr val="E97132"/>
+      </a:accent2>
+      <a:accent3>
+        <a:srgbClr val="196B24"/>
+      </a:accent3>
+      <a:accent4>
+        <a:srgbClr val="0F9ED5"/>
+      </a:accent4>
+      <a:accent5>
+        <a:srgbClr val="A02B93"/>
+      </a:accent5>
+      <a:accent6>
+        <a:srgbClr val="4EA72E"/>
+      </a:accent6>
+      <a:hlink>
+        <a:srgbClr val="467886"/>
+      </a:hlink>
+      <a:folHlink>
+        <a:srgbClr val="96607D"/>
+      </a:folHlink>
+    </a:clrScheme>
+    <a:fontScheme name="Office">
+      <a:majorFont>
+        <a:latin typeface="Aptos Display" panose="02110004020202020204"/>
+        <a:ea typeface=""/>
+        <a:cs typeface=""/>
+        <a:font script="Jpan" typeface="游ゴシック Light"/>
+        <a:font script="Hang" typeface="맑은 고딕"/>
+        <a:font script="Hans" typeface="等线 Light"/>
+        <a:font script="Hant" typeface="新細明體"/>
+        <a:font script="Arab" typeface="Times New Roman"/>
+        <a:font script="Hebr" typeface="Times New Roman"/>
+        <a:font script="Thai" typeface="Angsana New"/>
+        <a:font script="Ethi" typeface="Nyala"/>
+        <a:font script="Beng" typeface="Vrinda"/>
+        <a:font script="Gujr" typeface="Shruti"/>
+        <a:font script="Khmr" typeface="MoolBoran"/>
+        <a:font script="Knda" typeface="Tunga"/>
+        <a:font script="Guru" typeface="Raavi"/>
+        <a:font script="Cans" typeface="Euphemia"/>
+        <a:font script="Cher" typeface="Plantagenet Cherokee"/>
+        <a:font script="Yiii" typeface="Microsoft Yi Baiti"/>
+        <a:font script="Tibt" typeface="Microsoft Himalaya"/>
+        <a:font script="Thaa" typeface="MV Boli"/>
+        <a:font script="Deva" typeface="Mangal"/>
+        <a:font script="Telu" typeface="Gautami"/>
+        <a:font script="Taml" typeface="Latha"/>
+        <a:font script="Syrc" typeface="Estrangelo Edessa"/>
+        <a:font script="Orya" typeface="Kalinga"/>
+        <a:font script="Mlym" typeface="Kartika"/>
+        <a:font script="Laoo" typeface="DokChampa"/>
+        <a:font script="Sinh" typeface="Iskoola Pota"/>
+        <a:font script="Mong" typeface="Mongolian Baiti"/>
+        <a:font script="Viet" typeface="Times New Roman"/>
+        <a:font script="Uigh" typeface="Microsoft Uighur"/>
+        <a:font script="Geor" typeface="Sylfaen"/>
+        <a:font script="Armn" typeface="Arial"/>
+        <a:font script="Bugi" typeface="Leelawadee UI"/>
+        <a:font script="Bopo" typeface="Microsoft JhengHei"/>
+        <a:font script="Java" typeface="Javanese Text"/>
+        <a:font script="Lisu" typeface="Segoe UI"/>
+        <a:font script="Mymr" typeface="Myanmar Text"/>
+        <a:font script="Nkoo" typeface="Ebrima"/>
+        <a:font script="Olck" typeface="Nirmala UI"/>
+        <a:font script="Osma" typeface="Ebrima"/>
+        <a:font script="Phag" typeface="Phagspa"/>
+        <a:font script="Syrn" typeface="Estrangelo Edessa"/>
+        <a:font script="Syrj" typeface="Estrangelo Edessa"/>
+        <a:font script="Syre" typeface="Estrangelo Edessa"/>
+        <a:font script="Sora" typeface="Nirmala UI"/>
+        <a:font script="Tale" typeface="Microsoft Tai Le"/>
+        <a:font script="Talu" typeface="Microsoft New Tai Lue"/>
+        <a:font script="Tfng" typeface="Ebrima"/>
+      </a:majorFont>
+      <a:minorFont>
+        <a:latin typeface="Aptos" panose="02110004020202020204"/>
+        <a:ea typeface=""/>
+        <a:cs typeface=""/>
+        <a:font script="Jpan" typeface="游ゴシック"/>
+        <a:font script="Hang" typeface="맑은 고딕"/>
+        <a:font script="Hans" typeface="等线"/>
+        <a:font script="Hant" typeface="新細明體"/>
+        <a:font script="Arab" typeface="Arial"/>
+        <a:font script="Hebr" typeface="Arial"/>
+        <a:font script="Thai" typeface="Cordia New"/>
+        <a:font script="Ethi" typeface="Nyala"/>
+        <a:font script="Beng" typeface="Vrinda"/>
+        <a:font script="Gujr" typeface="Shruti"/>
+        <a:font script="Khmr" typeface="DaunPenh"/>
+        <a:font script="Knda" typeface="Tunga"/>
+        <a:font script="Guru" typeface="Raavi"/>
+        <a:font script="Cans" typeface="Euphemia"/>
+        <a:font script="Cher" typeface="Plantagenet Cherokee"/>
+        <a:font script="Yiii" typeface="Microsoft Yi Baiti"/>
+        <a:font script="Tibt" typeface="Microsoft Himalaya"/>
+        <a:font script="Thaa" typeface="MV Boli"/>
+        <a:font script="Deva" typeface="Mangal"/>
+        <a:font script="Telu" typeface="Gautami"/>
+        <a:font script="Taml" typeface="Latha"/>
+        <a:font script="Syrc" typeface="Estrangelo Edessa"/>
+        <a:font script="Orya" typeface="Kalinga"/>
+        <a:font script="Mlym" typeface="Kartika"/>
+        <a:font script="Laoo" typeface="DokChampa"/>
+        <a:font script="Sinh" typeface="Iskoola Pota"/>
+        <a:font script="Mong" typeface="Mongolian Baiti"/>
+        <a:font script="Viet" typeface="Arial"/>
+        <a:font script="Uigh" typeface="Microsoft Uighur"/>
+        <a:font script="Geor" typeface="Sylfaen"/>
+        <a:font script="Armn" typeface="Arial"/>
+        <a:font script="Bugi" typeface="Leelawadee UI"/>
+        <a:font script="Bopo" typeface="Microsoft JhengHei"/>
+        <a:font script="Java" typeface="Javanese Text"/>
+        <a:font script="Lisu" typeface="Segoe UI"/>
+        <a:font script="Mymr" typeface="Myanmar Text"/>
+        <a:font script="Nkoo" typeface="Ebrima"/>
+        <a:font script="Olck" typeface="Nirmala UI"/>
+        <a:font script="Osma" typeface="Ebrima"/>
+        <a:font script="Phag" typeface="Phagspa"/>
+        <a:font script="Syrn" typeface="Estrangelo Edessa"/>
+        <a:font script="Syrj" typeface="Estrangelo Edessa"/>
+        <a:font script="Syre" typeface="Estrangelo Edessa"/>
+        <a:font script="Sora" typeface="Nirmala UI"/>
+        <a:font script="Tale" typeface="Microsoft Tai Le"/>
+        <a:font script="Talu" typeface="Microsoft New Tai Lue"/>
+        <a:font script="Tfng" typeface="Ebrima"/>
+      </a:minorFont>
+    </a:fontScheme>
+    <a:fmtScheme name="Office">
+      <a:fillStyleLst>
+        <a:solidFill>
+          <a:schemeClr val="phClr"/>
+        </a:solidFill>
+        <a:gradFill rotWithShape="1">
+          <a:gsLst>
+            <a:gs pos="0">
+              <a:schemeClr val="phClr">
+                <a:lumMod val="110000"/>
+                <a:satMod val="105000"/>
+                <a:tint val="67000"/>
+              </a:schemeClr>
+            </a:gs>
+            <a:gs pos="50000">
+              <a:schemeClr val="phClr">
+                <a:lumMod val="105000"/>
+                <a:satMod val="103000"/>
+                <a:tint val="73000"/>
+              </a:schemeClr>
+            </a:gs>
+            <a:gs pos="100000">
+              <a:schemeClr val="phClr">
+                <a:lumMod val="105000"/>
+                <a:satMod val="109000"/>
+                <a:tint val="81000"/>
+              </a:schemeClr>
+            </a:gs>
+          </a:gsLst>
+          <a:lin ang="5400000" scaled="0"/>
+        </a:gradFill>
+        <a:gradFill rotWithShape="1">
+          <a:gsLst>
+            <a:gs pos="0">
+              <a:schemeClr val="phClr">
+                <a:satMod val="103000"/>
+                <a:lumMod val="102000"/>
+                <a:tint val="94000"/>
+              </a:schemeClr>
+            </a:gs>
+            <a:gs pos="50000">
+              <a:schemeClr val="phClr">
+                <a:satMod val="110000"/>
+                <a:lumMod val="100000"/>
+                <a:shade val="100000"/>
+              </a:schemeClr>
+            </a:gs>
+            <a:gs pos="100000">
+              <a:schemeClr val="phClr">
+                <a:lumMod val="99000"/>
+                <a:satMod val="120000"/>
+                <a:shade val="78000"/>
+              </a:schemeClr>
+            </a:gs>
+          </a:gsLst>
+          <a:lin ang="5400000" scaled="0"/>
+        </a:gradFill>
+      </a:fillStyleLst>
+      <a:lnStyleLst>
+        <a:ln w="12700" cap="flat" cmpd="sng" algn="ctr">
+          <a:solidFill>
+            <a:schemeClr val="phClr"/>
+          </a:solidFill>
+          <a:prstDash val="solid"/>
+          <a:miter lim="800000"/>
+        </a:ln>
+        <a:ln w="19050" cap="flat" cmpd="sng" algn="ctr">
+          <a:solidFill>
+            <a:schemeClr val="phClr"/>
+          </a:solidFill>
+          <a:prstDash val="solid"/>
+          <a:miter lim="800000"/>
+        </a:ln>
+        <a:ln w="25400" cap="flat" cmpd="sng" algn="ctr">
+          <a:solidFill>
+            <a:schemeClr val="phClr"/>
+          </a:solidFill>
+          <a:prstDash val="solid"/>
+          <a:miter lim="800000"/>
+        </a:ln>
+      </a:lnStyleLst>
+      <a:effectStyleLst>
+        <a:effectStyle>
+          <a:effectLst/>
+        </a:effectStyle>
+        <a:effectStyle>
+          <a:effectLst/>
+        </a:effectStyle>
+        <a:effectStyle>
+          <a:effectLst>
+            <a:outerShdw blurRad="57150" dist="19050" dir="5400000" algn="ctr" rotWithShape="0">
+              <a:srgbClr val="000000">
+                <a:alpha val="63000"/>
+              </a:srgbClr>
+            </a:outerShdw>
+          </a:effectLst>
+        </a:effectStyle>
+      </a:effectStyleLst>
+      <a:bgFillStyleLst>
+        <a:solidFill>
+          <a:schemeClr val="phClr"/>
+        </a:solidFill>
+        <a:solidFill>
+          <a:schemeClr val="phClr">
+            <a:tint val="95000"/>
+            <a:satMod val="170000"/>
+          </a:schemeClr>
+        </a:solidFill>
+        <a:gradFill rotWithShape="1">
+          <a:gsLst>
+            <a:gs pos="0">
+              <a:schemeClr val="phClr">
+                <a:tint val="93000"/>
+                <a:satMod val="150000"/>
+                <a:shade val="98000"/>
+                <a:lumMod val="102000"/>
+              </a:schemeClr>
+            </a:gs>
+            <a:gs pos="50000">
+              <a:schemeClr val="phClr">
+                <a:tint val="98000"/>
+                <a:satMod val="130000"/>
+                <a:shade val="90000"/>
+                <a:lumMod val="103000"/>
+              </a:schemeClr>
+            </a:gs>
+            <a:gs pos="100000">
+              <a:schemeClr val="phClr">
+                <a:shade val="63000"/>
+                <a:satMod val="120000"/>
+              </a:schemeClr>
+            </a:gs>
+          </a:gsLst>
+          <a:lin ang="5400000" scaled="0"/>
+        </a:gradFill>
+      </a:bgFillStyleLst>
+    </a:fmtScheme>
+  </a:themeElements>
+  <a:objectDefaults>
+    <a:lnDef>
+      <a:spPr/>
+      <a:bodyPr/>
+      <a:lstStyle/>
+      <a:style>
+        <a:lnRef idx="2">
+          <a:schemeClr val="accent1"/>
+        </a:lnRef>
+        <a:fillRef idx="0">
+          <a:schemeClr val="accent1"/>
+        </a:fillRef>
+        <a:effectRef idx="1">
+          <a:schemeClr val="accent1"/>
+        </a:effectRef>
+        <a:fontRef idx="minor">
+          <a:schemeClr val="tx1"/>
+        </a:fontRef>
+      </a:style>
+    </a:lnDef>
+  </a:objectDefaults>
+  <a:extraClrSchemeLst/>
+  <a:extLst>
+    <a:ext uri="{05A4C25C-085E-4340-85A3-A5531E510DB2}">
+      <thm15:themeFamily xmlns:thm15="http://schemas.microsoft.com/office/thememl/2012/main" name="Office Theme" id="{2E142A2C-CD16-42D6-873A-C26D2A0506FA}" vid="{1BDDFF52-6CD6-40A5-AB3C-68EB2F1E4D0A}"/>
+    </a:ext>
+  </a:extLst>
+</a:theme>
+</file>
+
 <file path=docMetadata/LabelInfo.xml><?xml version="1.0" encoding="utf-8"?>
 <clbl:labelList xmlns:clbl="http://schemas.microsoft.com/office/2020/mipLabelMetadata">
   <clbl:label id="{87ba5c36-b7cf-4793-bbc2-bd5b3a9f95ca}" enabled="1" method="Privileged" siteId="{72f988bf-86f1-41af-91ab-2d7cd011db47}" removed="0"/>

</xml_diff>